<commit_message>
Apply report review: loss, promotion rule, statistics, tests, Windows setup
- Explain the policy-loss implementation exactly (log-probabilities into
  log_softmax) and correct the L2 coefficient: weight decay 1e-4 is
  c = 5e-5 in the loss, half the paper's value.
- Distinguish the paper's promotion rule (> 55% of 400 games) from ours
  (>= 55% of 20-40 games); iteration 7 would not pass the paper's rule.
- Replace "statistically clear" with the binomial test for iteration 9
  and its independence caveat.
- Describe the project as a scaled-down version of AlphaGo Zero.
- Test count: 101 tests, all passing; 2 need httpx. Add Windows steps.
- Remove the uncited Medium reference.
- Bring the slides' notes, scripts, explanations and
  Final_Training_Report.md in line; drop the unverified iteration 1-2
  results from Final_Training_Report.md.
</commit_message>
<xml_diff>
--- a/Final_Submission/AlphaGoZero_Presentation.pptx
+++ b/Final_Submission/AlphaGoZero_Presentation.pptx
@@ -1435,7 +1435,7 @@
           <a:p>
             <a:r>
               <a:rPr lang="en-US" dirty="0"/>
-              <a:t>Algorithm six decides whether a new network is really better. The candidate plays an arena match against the current best. Colours alternate, the first 8 moves are sampled so that the games differ, and games are capped at 500 moves. From iteration 8 onward we play 40 games, and the candidate must win at least 55 percent to be promoted.</a:t>
+              <a:t>Algorithm six decides whether a new network is really better. The candidate plays an arena match against the current best. Colours alternate, the first 8 moves are sampled so that the games differ, and games are capped at 500 moves. From iteration 8 onward we play 40 games, and the candidate must win at least 55 percent to be promoted. The paper is stricter: more than 55 percent over 400 games.</a:t>
             </a:r>
           </a:p>
           <a:p>
@@ -1639,7 +1639,7 @@
           <a:p>
             <a:r>
               <a:rPr lang="en-US" dirty="0"/>
-              <a:t>Iteration 9 is our final best model, and that result is statistically clear: about 2.8 standard errors above an even match. The other five candidates were rejected, but most of them scored between 45 and 52.5 percent, which is essentially a tie with the model they played, not a regression. This shows that the self-play loop really does produce stronger networks without any human data.</a:t>
+              <a:t>Iteration 9 is our final best model, and that result is unlikely to be luck: if the two models were equally strong, winning 29 or more of 40 games would happen less than 1 percent of the time. The other five candidates were rejected, but most of them scored between 45 and 52.5 percent, which is essentially a tie with the model they played, not a regression. This shows that the self-play loop really does produce stronger networks without any human data.</a:t>
             </a:r>
           </a:p>
         </p:txBody>
@@ -2140,7 +2140,7 @@
           <a:p>
             <a:r>
               <a:rPr lang="en-US" dirty="0"/>
-              <a:t>To run it, you pull the models, install the requirements and run train_batched.py with a stage number. Because self-play is saved in batches, a stopped run can be restarted with the same command. The project also has a test suite of 99 passing unit tests.</a:t>
+              <a:t>To run it, you pull the models, install the requirements and run train_batched.py with a stage number. Because self-play is saved in batches, a stopped run can be restarted with the same command. The project also has 101 unit tests, and all of them pass.</a:t>
             </a:r>
           </a:p>
         </p:txBody>
@@ -2425,7 +2425,7 @@
           <a:p>
             <a:r>
               <a:rPr lang="en-US" dirty="0"/>
-              <a:t>To conclude: we implemented the complete AlphaGo Zero loop, with Go rules, a dual-head residual network, PUCT tree search, self-play, training and arena evaluation, and trained it from scratch on a single laptop. Over ten iterations three models were promoted, and iteration 9 is our best, winning 72.5 percent against its predecessor.</a:t>
+              <a:t>To conclude: we implemented a scaled-down version of the AlphaGo Zero loop, with Go rules, a dual-head residual network, PUCT tree search, self-play, training and arena evaluation, and trained it from scratch on a single laptop. Over ten iterations three models were promoted, and iteration 9 is our best, winning 72.5 percent against its predecessor.</a:t>
             </a:r>
           </a:p>
           <a:p>
@@ -14560,7 +14560,7 @@
                 <a:ea typeface="Calibri" pitchFamily="34" charset="-122"/>
                 <a:cs typeface="Calibri" pitchFamily="34" charset="-120"/>
               </a:rPr>
-              <a:t>We implemented the full AlphaGo Zero loop: Go rules, a dual-head ResNet, PUCT MCTS, self-play, training and arena evaluation.</a:t>
+              <a:t>We implemented a scaled-down version of the AlphaGo Zero loop: Go rules, a dual-head ResNet, PUCT MCTS, self-play, training and arena evaluation.</a:t>
             </a:r>
             <a:endParaRPr lang="en-US" sz="1800" dirty="0"/>
           </a:p>

</xml_diff>